<commit_message>
Add bracket L+U-bolt design doc with 3D viewer; reorganize CAD files
- New Deliverables/Desain_Bracket_L_UBolt_GLD_Mounting.{html,pdf}:
  industry standards (BS 3974, DIN 3570/3567, ASME B18.31.2, MSS SP-58/69)
  plus actual GLD "ATEX Casing v2" design spec, with a self-contained
  WebGL 3D viewer rendering the CAD .obj/.mtl directly (no external libs).
- Sumber Dokumen/GLD U-Bolt Bracket V2.png moved into
  Sumber Dokumen/GLD U Bolt Bracket/ alongside 6 orthographic renders
  and the 3D CAD source files (.obj/.mtl/.step).
- Nav bar regenerated across all 7 linked deliverables.
- memory/ updated with new gate:bracket-orientation finding (vertical
  pole vs horizontal handrail mounting not yet verified in writing).
</commit_message>
<xml_diff>
--- a/Deliverables/Presentasi_Progres_GLD_Sertifikasi_FieldTesting_Sep2026.pptx
+++ b/Deliverables/Presentasi_Progres_GLD_Sertifikasi_FieldTesting_Sep2026.pptx
@@ -2074,7 +2074,7 @@
                 <a:ea typeface="Cambria" pitchFamily="34" charset="-122"/>
                 <a:cs typeface="Cambria" pitchFamily="34" charset="-120"/>
               </a:rPr>
-              <a:t>39%</a:t>
+              <a:t>44%</a:t>
             </a:r>
             <a:endParaRPr lang="en-US" sz="4600" dirty="0"/>
           </a:p>
@@ -2152,7 +2152,7 @@
                 <a:ea typeface="Calibri" pitchFamily="34" charset="-122"/>
                 <a:cs typeface="Calibri" pitchFamily="34" charset="-120"/>
               </a:rPr>
-              <a:t>vs baseline resmi 19% (+20 poin). Murni sisi engineering lab — bukan kesiapan lapangan.</a:t>
+              <a:t>vs baseline resmi 43% per 4 Sep (+1 poin, menyusut dari +20 poin/24 Jul). Murni sisi engineering lab — bukan kesiapan lapangan.</a:t>
             </a:r>
             <a:endParaRPr lang="en-US" sz="950" dirty="0"/>
           </a:p>
@@ -7205,7 +7205,7 @@
                 <a:ea typeface="Calibri" pitchFamily="34" charset="-122"/>
                 <a:cs typeface="Calibri" pitchFamily="34" charset="-120"/>
               </a:rPr>
-              <a:t>gate:net-registration — prosedur registrasi jaringan kilang belum dikonfirmasi Pertamina.</a:t>
+              <a:t>✓ Jaringan field GLD↔server berjalan independen (router LGU sendiri) — tidak perlu registrasi ke IT kilang.</a:t>
             </a:r>
             <a:endParaRPr lang="en-US" sz="980" dirty="0"/>
           </a:p>
@@ -8412,7 +8412,7 @@
                 <a:ea typeface="Calibri" pitchFamily="34" charset="-122"/>
                 <a:cs typeface="Calibri" pitchFamily="34" charset="-120"/>
               </a:rPr>
-              <a:t>Menunggu jawaban Pertamina</a:t>
+              <a:t>Selesai — jaringan field independen (LGU)</a:t>
             </a:r>
             <a:endParaRPr lang="en-US" sz="1000" dirty="0"/>
           </a:p>
@@ -8549,7 +8549,7 @@
                 <a:ea typeface="Calibri" pitchFamily="34" charset="-122"/>
                 <a:cs typeface="Calibri" pitchFamily="34" charset="-120"/>
               </a:rPr>
-              <a:t>Menunggu konfirmasi Pertamina</a:t>
+              <a:t>Menunggu pengadaan PC fisik (bukan lagi soal jaringan)</a:t>
             </a:r>
             <a:endParaRPr lang="en-US" sz="1000" dirty="0"/>
           </a:p>
@@ -9506,7 +9506,7 @@
                 <a:ea typeface="Calibri" pitchFamily="34" charset="-122"/>
                 <a:cs typeface="Calibri" pitchFamily="34" charset="-120"/>
               </a:rPr>
-              <a:t>Menindaklanjuti konfirmasi Pertamina atas gate jaringan &amp; server (net-registration, server-spec, dashboard-exposure).</a:t>
+              <a:t>Menindaklanjuti konfirmasi Pertamina atas pengadaan PC fisik &amp; keamanan akses dashboard (server-spec, dashboard-exposure) — jaringan field sendiri sudah beres.</a:t>
             </a:r>
             <a:endParaRPr lang="en-US" sz="1250" dirty="0"/>
           </a:p>

</xml_diff>